<commit_message>
docs: add student ID and confirm course workload allocation
</commit_message>
<xml_diff>
--- a/docs/deliverables/下午班-08组-WEMOVE-SPORTS-项目汇报-v1.3.pptx
+++ b/docs/deliverables/下午班-08组-WEMOVE-SPORTS-项目汇报-v1.3.pptx
@@ -2,27 +2,27 @@
 <file path=ppt/presentation.xml><?xml version="1.0" encoding="utf-8"?>
 <p:presentation xmlns:p="http://schemas.openxmlformats.org/presentationml/2006/main">
   <p:sldMasterIdLst>
-    <p:sldMasterId xmlns:r="http://schemas.openxmlformats.org/officeDocument/2006/relationships" id="2147483648" r:id="R45f93fabffe44124"/>
+    <p:sldMasterId xmlns:r="http://schemas.openxmlformats.org/officeDocument/2006/relationships" id="2147483648" r:id="Ra138ae3e7dce45e4"/>
   </p:sldMasterIdLst>
   <p:notesMasterIdLst>
-    <p:notesMasterId xmlns:r="http://schemas.openxmlformats.org/officeDocument/2006/relationships" r:id="R5aa47e2349ff4a09"/>
+    <p:notesMasterId xmlns:r="http://schemas.openxmlformats.org/officeDocument/2006/relationships" r:id="R48e9c8ebbb284ff5"/>
   </p:notesMasterIdLst>
   <p:sldIdLst>
-    <p:sldId xmlns:r="http://schemas.openxmlformats.org/officeDocument/2006/relationships" id="256" r:id="R6f024782f656428f"/>
-    <p:sldId xmlns:r="http://schemas.openxmlformats.org/officeDocument/2006/relationships" id="257" r:id="R70e7e2a68a06424a"/>
-    <p:sldId xmlns:r="http://schemas.openxmlformats.org/officeDocument/2006/relationships" id="258" r:id="Ra47238c703c04d3e"/>
-    <p:sldId xmlns:r="http://schemas.openxmlformats.org/officeDocument/2006/relationships" id="259" r:id="R0f336948755a4f77"/>
-    <p:sldId xmlns:r="http://schemas.openxmlformats.org/officeDocument/2006/relationships" id="260" r:id="R8118a88dd2e34878"/>
-    <p:sldId xmlns:r="http://schemas.openxmlformats.org/officeDocument/2006/relationships" id="261" r:id="Rfc9db57b04a148ac"/>
-    <p:sldId xmlns:r="http://schemas.openxmlformats.org/officeDocument/2006/relationships" id="262" r:id="R2b08a430efdd47e9"/>
-    <p:sldId xmlns:r="http://schemas.openxmlformats.org/officeDocument/2006/relationships" id="263" r:id="R4f68856d87dc461c"/>
-    <p:sldId xmlns:r="http://schemas.openxmlformats.org/officeDocument/2006/relationships" id="264" r:id="R66031b83bf7a4588"/>
-    <p:sldId xmlns:r="http://schemas.openxmlformats.org/officeDocument/2006/relationships" id="265" r:id="Rb79ceb99bb7d42d0"/>
-    <p:sldId xmlns:r="http://schemas.openxmlformats.org/officeDocument/2006/relationships" id="266" r:id="Rf662ab2a7ef347cf"/>
-    <p:sldId xmlns:r="http://schemas.openxmlformats.org/officeDocument/2006/relationships" id="267" r:id="R7d3f4d499dec42ff"/>
-    <p:sldId xmlns:r="http://schemas.openxmlformats.org/officeDocument/2006/relationships" id="268" r:id="Re450164c159e4ecc"/>
-    <p:sldId xmlns:r="http://schemas.openxmlformats.org/officeDocument/2006/relationships" id="269" r:id="Re4c4a6c0780644e4"/>
-    <p:sldId xmlns:r="http://schemas.openxmlformats.org/officeDocument/2006/relationships" id="270" r:id="R6569a0d98c1f4a4d"/>
+    <p:sldId xmlns:r="http://schemas.openxmlformats.org/officeDocument/2006/relationships" id="256" r:id="Reb14e03b40af4d25"/>
+    <p:sldId xmlns:r="http://schemas.openxmlformats.org/officeDocument/2006/relationships" id="257" r:id="R3bea106e5f2f4413"/>
+    <p:sldId xmlns:r="http://schemas.openxmlformats.org/officeDocument/2006/relationships" id="258" r:id="Rc84a4038fc61482e"/>
+    <p:sldId xmlns:r="http://schemas.openxmlformats.org/officeDocument/2006/relationships" id="259" r:id="Rc273e6a607fd484d"/>
+    <p:sldId xmlns:r="http://schemas.openxmlformats.org/officeDocument/2006/relationships" id="260" r:id="Ra11d82b5a68e4ab9"/>
+    <p:sldId xmlns:r="http://schemas.openxmlformats.org/officeDocument/2006/relationships" id="261" r:id="Rb8b6e450c2314405"/>
+    <p:sldId xmlns:r="http://schemas.openxmlformats.org/officeDocument/2006/relationships" id="262" r:id="Rc326c7132bca4464"/>
+    <p:sldId xmlns:r="http://schemas.openxmlformats.org/officeDocument/2006/relationships" id="263" r:id="R3c680b7af2f042a7"/>
+    <p:sldId xmlns:r="http://schemas.openxmlformats.org/officeDocument/2006/relationships" id="264" r:id="Rc2141809eb56471b"/>
+    <p:sldId xmlns:r="http://schemas.openxmlformats.org/officeDocument/2006/relationships" id="265" r:id="R981c5afe784e43d4"/>
+    <p:sldId xmlns:r="http://schemas.openxmlformats.org/officeDocument/2006/relationships" id="266" r:id="R245668a787a24d2a"/>
+    <p:sldId xmlns:r="http://schemas.openxmlformats.org/officeDocument/2006/relationships" id="267" r:id="Rcd0b7ab00a0c4603"/>
+    <p:sldId xmlns:r="http://schemas.openxmlformats.org/officeDocument/2006/relationships" id="268" r:id="Rab9940c9f6354e7c"/>
+    <p:sldId xmlns:r="http://schemas.openxmlformats.org/officeDocument/2006/relationships" id="269" r:id="R6be1cc8c69e04bdb"/>
+    <p:sldId xmlns:r="http://schemas.openxmlformats.org/officeDocument/2006/relationships" id="270" r:id="R765d6d6438924521"/>
   </p:sldIdLst>
   <p:sldSz cx="12192000" cy="6858000"/>
   <p:notesSz cx="6858000" cy="9144000"/>
@@ -1016,7 +1016,7 @@
           <a:lstStyle xmlns:a="http://schemas.openxmlformats.org/drawingml/2006/main"/>
           <a:p xmlns:a="http://schemas.openxmlformats.org/drawingml/2006/main">
             <a:r>
-              <a:t>来源：docs/plans/workload-current.md。25% + 18.75% × 4 = 100%，为既定任务分配比例。</a:t>
+              <a:t>来源：docs/plans/workload-current.md。25% + 18.75% × 4 = 100%，为组长确认的课程提交工作量占比。</a:t>
             </a:r>
           </a:p>
         </p:txBody>
@@ -1504,7 +1504,7 @@
   </p:cSld>
   <p:clrMap bg1="lt1" tx1="dk1" bg2="lt2" tx2="dk2" accent1="accent1" accent2="accent2" accent3="accent3" accent4="accent4" accent5="accent5" accent6="accent6" hlink="hlink" folHlink="folHlink"/>
   <p:sldLayoutIdLst>
-    <p:sldLayoutId xmlns:r="http://schemas.openxmlformats.org/officeDocument/2006/relationships" id="2147483649" r:id="R4f079320029a4ea2"/>
+    <p:sldLayoutId xmlns:r="http://schemas.openxmlformats.org/officeDocument/2006/relationships" id="2147483649" r:id="Rc8894353dbcf4dc5"/>
   </p:sldLayoutIdLst>
   <p:txStyles>
     <p:titleStyle>
@@ -2059,7 +2059,7 @@
           <p:nvPr/>
         </p:nvPicPr>
         <p:blipFill>
-          <a:blip xmlns:r="http://schemas.openxmlformats.org/officeDocument/2006/relationships" xmlns:a="http://schemas.openxmlformats.org/drawingml/2006/main" r:embed="Re659f2756f964776"/>
+          <a:blip xmlns:r="http://schemas.openxmlformats.org/officeDocument/2006/relationships" xmlns:a="http://schemas.openxmlformats.org/drawingml/2006/main" r:embed="Ra88ab8bbe23044ae"/>
           <a:srcRect xmlns:a="http://schemas.openxmlformats.org/drawingml/2006/main" l="19630" t="0" r="19630" b="0"/>
           <a:stretch xmlns:a="http://schemas.openxmlformats.org/drawingml/2006/main">
             <a:fillRect l="0" t="0" r="0" b="0"/>
@@ -2080,7 +2080,7 @@
           <p:cNvPr id="2" name="">
             <a:extLst xmlns:a="http://schemas.openxmlformats.org/drawingml/2006/main">
               <a:ext uri="{FF2B5EF4-FFF2-40B4-BE49-F238E27FC236}">
-                <a16:creationId xmlns:a16="http://schemas.microsoft.com/office/drawing/2014/main" id="{5A7C4EFF-93A6-4BD3-A5BA-9B31746C9321}"/>
+                <a16:creationId xmlns:a16="http://schemas.microsoft.com/office/drawing/2014/main" id="{5AE7CFDD-F24C-45CE-AA66-E38FDA1367A9}"/>
               </a:ext>
             </a:extLst>
           </p:cNvPr>
@@ -2137,7 +2137,7 @@
           <p:cNvPr id="3" name="">
             <a:extLst xmlns:a="http://schemas.openxmlformats.org/drawingml/2006/main">
               <a:ext uri="{FF2B5EF4-FFF2-40B4-BE49-F238E27FC236}">
-                <a16:creationId xmlns:a16="http://schemas.microsoft.com/office/drawing/2014/main" id="{012D8BD1-9715-428A-ABDD-8E1E0C4895DD}"/>
+                <a16:creationId xmlns:a16="http://schemas.microsoft.com/office/drawing/2014/main" id="{228C3013-3332-4398-8E43-3F1DE25ADC10}"/>
               </a:ext>
             </a:extLst>
           </p:cNvPr>
@@ -2194,7 +2194,7 @@
           <p:cNvPr id="4" name="">
             <a:extLst xmlns:a="http://schemas.openxmlformats.org/drawingml/2006/main">
               <a:ext uri="{FF2B5EF4-FFF2-40B4-BE49-F238E27FC236}">
-                <a16:creationId xmlns:a16="http://schemas.microsoft.com/office/drawing/2014/main" id="{7A2D867D-13B8-4B98-BBA2-7433CDC6F395}"/>
+                <a16:creationId xmlns:a16="http://schemas.microsoft.com/office/drawing/2014/main" id="{2B49DF85-560C-4339-9A6C-9B40D9A9F495}"/>
               </a:ext>
             </a:extLst>
           </p:cNvPr>
@@ -2251,7 +2251,7 @@
           <p:cNvPr id="5" name="">
             <a:extLst xmlns:a="http://schemas.openxmlformats.org/drawingml/2006/main">
               <a:ext uri="{FF2B5EF4-FFF2-40B4-BE49-F238E27FC236}">
-                <a16:creationId xmlns:a16="http://schemas.microsoft.com/office/drawing/2014/main" id="{6AE68348-F1DC-492E-A7F2-D06D2219500D}"/>
+                <a16:creationId xmlns:a16="http://schemas.microsoft.com/office/drawing/2014/main" id="{6F34B38A-7A47-4EC5-BC2B-788F4B7D7EA6}"/>
               </a:ext>
             </a:extLst>
           </p:cNvPr>
@@ -2308,7 +2308,7 @@
           <p:cNvPr id="6" name="">
             <a:extLst xmlns:a="http://schemas.openxmlformats.org/drawingml/2006/main">
               <a:ext uri="{FF2B5EF4-FFF2-40B4-BE49-F238E27FC236}">
-                <a16:creationId xmlns:a16="http://schemas.microsoft.com/office/drawing/2014/main" id="{9C69C05C-BE88-4CED-93D2-7B8CF6A3F3F2}"/>
+                <a16:creationId xmlns:a16="http://schemas.microsoft.com/office/drawing/2014/main" id="{8721445E-4212-4DD2-94D8-CA019862A387}"/>
               </a:ext>
             </a:extLst>
           </p:cNvPr>
@@ -2365,7 +2365,7 @@
           <p:cNvPr id="7" name="">
             <a:extLst xmlns:a="http://schemas.openxmlformats.org/drawingml/2006/main">
               <a:ext uri="{FF2B5EF4-FFF2-40B4-BE49-F238E27FC236}">
-                <a16:creationId xmlns:a16="http://schemas.microsoft.com/office/drawing/2014/main" id="{7DDE459B-9FB4-4520-8DAF-20C958E75AE2}"/>
+                <a16:creationId xmlns:a16="http://schemas.microsoft.com/office/drawing/2014/main" id="{A62E1518-28EC-4928-A34A-4519ED343FFD}"/>
               </a:ext>
             </a:extLst>
           </p:cNvPr>
@@ -2443,7 +2443,7 @@
     </p:spTree>
     <p:extLst>
       <p:ext uri="{BB962C8B-B14F-4D97-AF65-F5344CB8AC3E}">
-        <p14:creationId xmlns:p14="http://schemas.microsoft.com/office/powerpoint/2010/main" val="1378952413"/>
+        <p14:creationId xmlns:p14="http://schemas.microsoft.com/office/powerpoint/2010/main" val="545051133"/>
       </p:ext>
     </p:extLst>
   </p:cSld>
@@ -2474,7 +2474,7 @@
           <p:cNvPr id="5" name="">
             <a:extLst xmlns:a="http://schemas.openxmlformats.org/drawingml/2006/main">
               <a:ext uri="{FF2B5EF4-FFF2-40B4-BE49-F238E27FC236}">
-                <a16:creationId xmlns:a16="http://schemas.microsoft.com/office/drawing/2014/main" id="{92F8A5EF-DADE-4B3C-9F4A-2F683993646F}"/>
+                <a16:creationId xmlns:a16="http://schemas.microsoft.com/office/drawing/2014/main" id="{B69E463D-FA44-4A7E-B5D0-92A6C7412679}"/>
               </a:ext>
             </a:extLst>
           </p:cNvPr>
@@ -3028,7 +3028,7 @@
           <p:cNvPr id="3" name="">
             <a:extLst xmlns:a="http://schemas.openxmlformats.org/drawingml/2006/main">
               <a:ext uri="{FF2B5EF4-FFF2-40B4-BE49-F238E27FC236}">
-                <a16:creationId xmlns:a16="http://schemas.microsoft.com/office/drawing/2014/main" id="{A5BB2AE0-D4E0-4EAA-96B5-D735469F6CB4}"/>
+                <a16:creationId xmlns:a16="http://schemas.microsoft.com/office/drawing/2014/main" id="{5094C7C7-DFF1-4366-9BD9-6C672C6FDB33}"/>
               </a:ext>
             </a:extLst>
           </p:cNvPr>
@@ -3085,7 +3085,7 @@
           <p:cNvPr id="4" name="">
             <a:extLst xmlns:a="http://schemas.openxmlformats.org/drawingml/2006/main">
               <a:ext uri="{FF2B5EF4-FFF2-40B4-BE49-F238E27FC236}">
-                <a16:creationId xmlns:a16="http://schemas.microsoft.com/office/drawing/2014/main" id="{3E0E47DB-FDC8-414A-98F7-F5ED3F641253}"/>
+                <a16:creationId xmlns:a16="http://schemas.microsoft.com/office/drawing/2014/main" id="{6C1C5D33-9F93-46CE-8C9D-E53D4E3603D6}"/>
               </a:ext>
             </a:extLst>
           </p:cNvPr>
@@ -3140,7 +3140,7 @@
     </p:spTree>
     <p:extLst>
       <p:ext uri="{BB962C8B-B14F-4D97-AF65-F5344CB8AC3E}">
-        <p14:creationId xmlns:p14="http://schemas.microsoft.com/office/powerpoint/2010/main" val="110166113"/>
+        <p14:creationId xmlns:p14="http://schemas.microsoft.com/office/powerpoint/2010/main" val="149255145"/>
       </p:ext>
     </p:extLst>
   </p:cSld>
@@ -3171,7 +3171,7 @@
           <p:cNvPr id="10" name="">
             <a:extLst xmlns:a="http://schemas.openxmlformats.org/drawingml/2006/main">
               <a:ext uri="{FF2B5EF4-FFF2-40B4-BE49-F238E27FC236}">
-                <a16:creationId xmlns:a16="http://schemas.microsoft.com/office/drawing/2014/main" id="{77910472-BD37-45BE-9EA0-A74771D53EC5}"/>
+                <a16:creationId xmlns:a16="http://schemas.microsoft.com/office/drawing/2014/main" id="{574D698B-5362-4338-BB31-EA3C0272E7DE}"/>
               </a:ext>
             </a:extLst>
           </p:cNvPr>
@@ -3232,7 +3232,7 @@
           <p:nvPr/>
         </p:nvPicPr>
         <p:blipFill>
-          <a:blip xmlns:r="http://schemas.openxmlformats.org/officeDocument/2006/relationships" xmlns:a="http://schemas.openxmlformats.org/drawingml/2006/main" r:embed="R2b1228a76c4645a1"/>
+          <a:blip xmlns:r="http://schemas.openxmlformats.org/officeDocument/2006/relationships" xmlns:a="http://schemas.openxmlformats.org/drawingml/2006/main" r:embed="R9abd3855e22746dc"/>
           <a:stretch xmlns:a="http://schemas.openxmlformats.org/drawingml/2006/main"/>
         </p:blipFill>
         <p:spPr>
@@ -3250,7 +3250,7 @@
           <p:cNvPr id="3" name="">
             <a:extLst xmlns:a="http://schemas.openxmlformats.org/drawingml/2006/main">
               <a:ext uri="{FF2B5EF4-FFF2-40B4-BE49-F238E27FC236}">
-                <a16:creationId xmlns:a16="http://schemas.microsoft.com/office/drawing/2014/main" id="{C35D8FB3-4739-4840-9BF5-4775E4FCD478}"/>
+                <a16:creationId xmlns:a16="http://schemas.microsoft.com/office/drawing/2014/main" id="{483B9E44-65F5-4C69-A47D-C869965BEEB7}"/>
               </a:ext>
             </a:extLst>
           </p:cNvPr>
@@ -3307,7 +3307,7 @@
           <p:cNvPr id="4" name="">
             <a:extLst xmlns:a="http://schemas.openxmlformats.org/drawingml/2006/main">
               <a:ext uri="{FF2B5EF4-FFF2-40B4-BE49-F238E27FC236}">
-                <a16:creationId xmlns:a16="http://schemas.microsoft.com/office/drawing/2014/main" id="{6A08C08F-6AF3-41DD-BD27-49899529DE04}"/>
+                <a16:creationId xmlns:a16="http://schemas.microsoft.com/office/drawing/2014/main" id="{E885682B-713F-4DE9-9F20-82A5DCCE4160}"/>
               </a:ext>
             </a:extLst>
           </p:cNvPr>
@@ -3410,7 +3410,7 @@
           <p:cNvPr id="5" name="">
             <a:extLst xmlns:a="http://schemas.openxmlformats.org/drawingml/2006/main">
               <a:ext uri="{FF2B5EF4-FFF2-40B4-BE49-F238E27FC236}">
-                <a16:creationId xmlns:a16="http://schemas.microsoft.com/office/drawing/2014/main" id="{ADE1C060-6038-4A65-A8CF-B60842D48549}"/>
+                <a16:creationId xmlns:a16="http://schemas.microsoft.com/office/drawing/2014/main" id="{EAE1BB57-085D-4F2D-A8FD-FB2B73DE1E33}"/>
               </a:ext>
             </a:extLst>
           </p:cNvPr>
@@ -3467,7 +3467,7 @@
           <p:cNvPr id="6" name="">
             <a:extLst xmlns:a="http://schemas.openxmlformats.org/drawingml/2006/main">
               <a:ext uri="{FF2B5EF4-FFF2-40B4-BE49-F238E27FC236}">
-                <a16:creationId xmlns:a16="http://schemas.microsoft.com/office/drawing/2014/main" id="{704333C4-326E-4C47-98AC-B4C1E5439EB6}"/>
+                <a16:creationId xmlns:a16="http://schemas.microsoft.com/office/drawing/2014/main" id="{AB3AE43F-1A0F-4E55-B553-DA522D02086E}"/>
               </a:ext>
             </a:extLst>
           </p:cNvPr>
@@ -3570,7 +3570,7 @@
           <p:cNvPr id="7" name="">
             <a:extLst xmlns:a="http://schemas.openxmlformats.org/drawingml/2006/main">
               <a:ext uri="{FF2B5EF4-FFF2-40B4-BE49-F238E27FC236}">
-                <a16:creationId xmlns:a16="http://schemas.microsoft.com/office/drawing/2014/main" id="{7AC8E3F9-2D27-45E8-AD9E-D634A562A767}"/>
+                <a16:creationId xmlns:a16="http://schemas.microsoft.com/office/drawing/2014/main" id="{81E7612F-A07E-4DB6-9E14-27EC4A94F4A5}"/>
               </a:ext>
             </a:extLst>
           </p:cNvPr>
@@ -3627,7 +3627,7 @@
           <p:cNvPr id="8" name="">
             <a:extLst xmlns:a="http://schemas.openxmlformats.org/drawingml/2006/main">
               <a:ext uri="{FF2B5EF4-FFF2-40B4-BE49-F238E27FC236}">
-                <a16:creationId xmlns:a16="http://schemas.microsoft.com/office/drawing/2014/main" id="{D25486E8-BD9F-45D2-A71E-EC520AEB39D1}"/>
+                <a16:creationId xmlns:a16="http://schemas.microsoft.com/office/drawing/2014/main" id="{8518AAA7-9B29-4DA3-9CA0-D1498FA13FD2}"/>
               </a:ext>
             </a:extLst>
           </p:cNvPr>
@@ -3730,7 +3730,7 @@
           <p:cNvPr id="9" name="">
             <a:extLst xmlns:a="http://schemas.openxmlformats.org/drawingml/2006/main">
               <a:ext uri="{FF2B5EF4-FFF2-40B4-BE49-F238E27FC236}">
-                <a16:creationId xmlns:a16="http://schemas.microsoft.com/office/drawing/2014/main" id="{291DD02B-03CF-4E05-B1BE-6361BEB0B9F4}"/>
+                <a16:creationId xmlns:a16="http://schemas.microsoft.com/office/drawing/2014/main" id="{8E5E3599-C77B-4204-A148-FC066334B343}"/>
               </a:ext>
             </a:extLst>
           </p:cNvPr>
@@ -3785,7 +3785,7 @@
     </p:spTree>
     <p:extLst>
       <p:ext uri="{BB962C8B-B14F-4D97-AF65-F5344CB8AC3E}">
-        <p14:creationId xmlns:p14="http://schemas.microsoft.com/office/powerpoint/2010/main" val="1329165667"/>
+        <p14:creationId xmlns:p14="http://schemas.microsoft.com/office/powerpoint/2010/main" val="2043873292"/>
       </p:ext>
     </p:extLst>
   </p:cSld>
@@ -3816,7 +3816,7 @@
           <p:cNvPr id="10" name="">
             <a:extLst xmlns:a="http://schemas.openxmlformats.org/drawingml/2006/main">
               <a:ext uri="{FF2B5EF4-FFF2-40B4-BE49-F238E27FC236}">
-                <a16:creationId xmlns:a16="http://schemas.microsoft.com/office/drawing/2014/main" id="{A03D5C85-2307-4736-BAD0-E7EC39045330}"/>
+                <a16:creationId xmlns:a16="http://schemas.microsoft.com/office/drawing/2014/main" id="{F3ECE44D-A8BE-4825-B15C-2C4EE97D2B82}"/>
               </a:ext>
             </a:extLst>
           </p:cNvPr>
@@ -3877,7 +3877,7 @@
           <p:nvPr/>
         </p:nvPicPr>
         <p:blipFill>
-          <a:blip xmlns:r="http://schemas.openxmlformats.org/officeDocument/2006/relationships" xmlns:a="http://schemas.openxmlformats.org/drawingml/2006/main" r:embed="R4e389a056e624952"/>
+          <a:blip xmlns:r="http://schemas.openxmlformats.org/officeDocument/2006/relationships" xmlns:a="http://schemas.openxmlformats.org/drawingml/2006/main" r:embed="Rd2863e0455144e80"/>
           <a:stretch xmlns:a="http://schemas.openxmlformats.org/drawingml/2006/main"/>
         </p:blipFill>
         <p:spPr>
@@ -3895,7 +3895,7 @@
           <p:cNvPr id="3" name="">
             <a:extLst xmlns:a="http://schemas.openxmlformats.org/drawingml/2006/main">
               <a:ext uri="{FF2B5EF4-FFF2-40B4-BE49-F238E27FC236}">
-                <a16:creationId xmlns:a16="http://schemas.microsoft.com/office/drawing/2014/main" id="{E13B1667-5EF3-469F-9F21-95910B329B12}"/>
+                <a16:creationId xmlns:a16="http://schemas.microsoft.com/office/drawing/2014/main" id="{63CFA20B-BE1D-4552-8353-3CAC76216A07}"/>
               </a:ext>
             </a:extLst>
           </p:cNvPr>
@@ -3952,7 +3952,7 @@
           <p:cNvPr id="4" name="">
             <a:extLst xmlns:a="http://schemas.openxmlformats.org/drawingml/2006/main">
               <a:ext uri="{FF2B5EF4-FFF2-40B4-BE49-F238E27FC236}">
-                <a16:creationId xmlns:a16="http://schemas.microsoft.com/office/drawing/2014/main" id="{7B538828-9B91-46E9-ACDB-480ED039ED04}"/>
+                <a16:creationId xmlns:a16="http://schemas.microsoft.com/office/drawing/2014/main" id="{1C250F6C-BAF2-4668-8AD6-8E7036874F06}"/>
               </a:ext>
             </a:extLst>
           </p:cNvPr>
@@ -4055,7 +4055,7 @@
           <p:cNvPr id="5" name="">
             <a:extLst xmlns:a="http://schemas.openxmlformats.org/drawingml/2006/main">
               <a:ext uri="{FF2B5EF4-FFF2-40B4-BE49-F238E27FC236}">
-                <a16:creationId xmlns:a16="http://schemas.microsoft.com/office/drawing/2014/main" id="{4C9B150A-34BC-4EAD-BEA6-C7909237854A}"/>
+                <a16:creationId xmlns:a16="http://schemas.microsoft.com/office/drawing/2014/main" id="{85F2FE97-8CD0-435A-8DE7-B36376882F27}"/>
               </a:ext>
             </a:extLst>
           </p:cNvPr>
@@ -4112,7 +4112,7 @@
           <p:cNvPr id="6" name="">
             <a:extLst xmlns:a="http://schemas.openxmlformats.org/drawingml/2006/main">
               <a:ext uri="{FF2B5EF4-FFF2-40B4-BE49-F238E27FC236}">
-                <a16:creationId xmlns:a16="http://schemas.microsoft.com/office/drawing/2014/main" id="{BA54039E-1401-4325-92E4-455DA1FB1C71}"/>
+                <a16:creationId xmlns:a16="http://schemas.microsoft.com/office/drawing/2014/main" id="{C049C61F-5B42-403E-8E28-FD234A6DB7BD}"/>
               </a:ext>
             </a:extLst>
           </p:cNvPr>
@@ -4215,7 +4215,7 @@
           <p:cNvPr id="7" name="">
             <a:extLst xmlns:a="http://schemas.openxmlformats.org/drawingml/2006/main">
               <a:ext uri="{FF2B5EF4-FFF2-40B4-BE49-F238E27FC236}">
-                <a16:creationId xmlns:a16="http://schemas.microsoft.com/office/drawing/2014/main" id="{A22E147B-18BF-4F34-9175-47C994CA5407}"/>
+                <a16:creationId xmlns:a16="http://schemas.microsoft.com/office/drawing/2014/main" id="{EC6EDC68-10E0-4584-8D05-DBE8819A37E5}"/>
               </a:ext>
             </a:extLst>
           </p:cNvPr>
@@ -4272,7 +4272,7 @@
           <p:cNvPr id="8" name="">
             <a:extLst xmlns:a="http://schemas.openxmlformats.org/drawingml/2006/main">
               <a:ext uri="{FF2B5EF4-FFF2-40B4-BE49-F238E27FC236}">
-                <a16:creationId xmlns:a16="http://schemas.microsoft.com/office/drawing/2014/main" id="{5E5A62CA-7963-4C8C-AB51-FFD13D809F0E}"/>
+                <a16:creationId xmlns:a16="http://schemas.microsoft.com/office/drawing/2014/main" id="{5F67DA4A-F414-4D9E-9D8C-918B6801BEA6}"/>
               </a:ext>
             </a:extLst>
           </p:cNvPr>
@@ -4375,7 +4375,7 @@
           <p:cNvPr id="9" name="">
             <a:extLst xmlns:a="http://schemas.openxmlformats.org/drawingml/2006/main">
               <a:ext uri="{FF2B5EF4-FFF2-40B4-BE49-F238E27FC236}">
-                <a16:creationId xmlns:a16="http://schemas.microsoft.com/office/drawing/2014/main" id="{C0D20248-3516-4944-945F-D1730418B0A5}"/>
+                <a16:creationId xmlns:a16="http://schemas.microsoft.com/office/drawing/2014/main" id="{C2BF6A04-2ABE-4D78-ACD8-071BD3E791EA}"/>
               </a:ext>
             </a:extLst>
           </p:cNvPr>
@@ -4430,7 +4430,7 @@
     </p:spTree>
     <p:extLst>
       <p:ext uri="{BB962C8B-B14F-4D97-AF65-F5344CB8AC3E}">
-        <p14:creationId xmlns:p14="http://schemas.microsoft.com/office/powerpoint/2010/main" val="1183811613"/>
+        <p14:creationId xmlns:p14="http://schemas.microsoft.com/office/powerpoint/2010/main" val="1312000893"/>
       </p:ext>
     </p:extLst>
   </p:cSld>
@@ -4461,7 +4461,7 @@
           <p:cNvPr id="11" name="">
             <a:extLst xmlns:a="http://schemas.openxmlformats.org/drawingml/2006/main">
               <a:ext uri="{FF2B5EF4-FFF2-40B4-BE49-F238E27FC236}">
-                <a16:creationId xmlns:a16="http://schemas.microsoft.com/office/drawing/2014/main" id="{61EA8A2D-9CEB-44E7-B424-EDE0D01143A3}"/>
+                <a16:creationId xmlns:a16="http://schemas.microsoft.com/office/drawing/2014/main" id="{01010BAD-16FA-40F9-921D-2A5D53CE4753}"/>
               </a:ext>
             </a:extLst>
           </p:cNvPr>
@@ -4518,7 +4518,7 @@
           <p:cNvPr id="2" name="">
             <a:extLst xmlns:a="http://schemas.openxmlformats.org/drawingml/2006/main">
               <a:ext uri="{FF2B5EF4-FFF2-40B4-BE49-F238E27FC236}">
-                <a16:creationId xmlns:a16="http://schemas.microsoft.com/office/drawing/2014/main" id="{CDA6E4A5-DFDA-491B-9831-C46D7FEDD253}"/>
+                <a16:creationId xmlns:a16="http://schemas.microsoft.com/office/drawing/2014/main" id="{E2CA01A7-C44B-4BA1-A622-D7DDB0FAE1C0}"/>
               </a:ext>
             </a:extLst>
           </p:cNvPr>
@@ -4575,7 +4575,7 @@
           <p:cNvPr id="3" name="">
             <a:extLst xmlns:a="http://schemas.openxmlformats.org/drawingml/2006/main">
               <a:ext uri="{FF2B5EF4-FFF2-40B4-BE49-F238E27FC236}">
-                <a16:creationId xmlns:a16="http://schemas.microsoft.com/office/drawing/2014/main" id="{75A00134-4B5D-4641-B155-B1765698DE59}"/>
+                <a16:creationId xmlns:a16="http://schemas.microsoft.com/office/drawing/2014/main" id="{44026D49-717E-46AA-AC06-16229D3D77DD}"/>
               </a:ext>
             </a:extLst>
           </p:cNvPr>
@@ -4632,7 +4632,7 @@
           <p:cNvPr id="4" name="">
             <a:extLst xmlns:a="http://schemas.openxmlformats.org/drawingml/2006/main">
               <a:ext uri="{FF2B5EF4-FFF2-40B4-BE49-F238E27FC236}">
-                <a16:creationId xmlns:a16="http://schemas.microsoft.com/office/drawing/2014/main" id="{643C9478-AA87-4FC3-B80E-B6A20C2FE702}"/>
+                <a16:creationId xmlns:a16="http://schemas.microsoft.com/office/drawing/2014/main" id="{1AD91139-C15D-441D-A84F-A5CD0E7FADA8}"/>
               </a:ext>
             </a:extLst>
           </p:cNvPr>
@@ -4689,7 +4689,7 @@
           <p:cNvPr id="5" name="">
             <a:extLst xmlns:a="http://schemas.openxmlformats.org/drawingml/2006/main">
               <a:ext uri="{FF2B5EF4-FFF2-40B4-BE49-F238E27FC236}">
-                <a16:creationId xmlns:a16="http://schemas.microsoft.com/office/drawing/2014/main" id="{A767974C-B001-4FBB-BBAA-3DE59BE660A4}"/>
+                <a16:creationId xmlns:a16="http://schemas.microsoft.com/office/drawing/2014/main" id="{84493B97-F85F-49DF-AF2C-D80CDF370378}"/>
               </a:ext>
             </a:extLst>
           </p:cNvPr>
@@ -4746,7 +4746,7 @@
           <p:cNvPr id="6" name="">
             <a:extLst xmlns:a="http://schemas.openxmlformats.org/drawingml/2006/main">
               <a:ext uri="{FF2B5EF4-FFF2-40B4-BE49-F238E27FC236}">
-                <a16:creationId xmlns:a16="http://schemas.microsoft.com/office/drawing/2014/main" id="{7482C968-CAFD-4D9C-9B4B-813BD49D16DC}"/>
+                <a16:creationId xmlns:a16="http://schemas.microsoft.com/office/drawing/2014/main" id="{03038BAE-23E3-422D-A72B-0D321546BF84}"/>
               </a:ext>
             </a:extLst>
           </p:cNvPr>
@@ -4803,7 +4803,7 @@
           <p:cNvPr id="7" name="">
             <a:extLst xmlns:a="http://schemas.openxmlformats.org/drawingml/2006/main">
               <a:ext uri="{FF2B5EF4-FFF2-40B4-BE49-F238E27FC236}">
-                <a16:creationId xmlns:a16="http://schemas.microsoft.com/office/drawing/2014/main" id="{4CA69201-261F-49B0-B350-467056516304}"/>
+                <a16:creationId xmlns:a16="http://schemas.microsoft.com/office/drawing/2014/main" id="{071F5D67-A8C6-43BD-858F-F32DCD47C45B}"/>
               </a:ext>
             </a:extLst>
           </p:cNvPr>
@@ -5132,7 +5132,7 @@
           <p:cNvPr id="9" name="">
             <a:extLst xmlns:a="http://schemas.openxmlformats.org/drawingml/2006/main">
               <a:ext uri="{FF2B5EF4-FFF2-40B4-BE49-F238E27FC236}">
-                <a16:creationId xmlns:a16="http://schemas.microsoft.com/office/drawing/2014/main" id="{44D9F044-C1C6-4ECB-81C3-3D9295EA64D8}"/>
+                <a16:creationId xmlns:a16="http://schemas.microsoft.com/office/drawing/2014/main" id="{8A262AD3-844A-4A9F-BF45-334A4FCA0BE2}"/>
               </a:ext>
             </a:extLst>
           </p:cNvPr>
@@ -5189,7 +5189,7 @@
           <p:cNvPr id="10" name="">
             <a:extLst xmlns:a="http://schemas.openxmlformats.org/drawingml/2006/main">
               <a:ext uri="{FF2B5EF4-FFF2-40B4-BE49-F238E27FC236}">
-                <a16:creationId xmlns:a16="http://schemas.microsoft.com/office/drawing/2014/main" id="{B58D1B94-AB19-4926-ABC9-241050F54E7B}"/>
+                <a16:creationId xmlns:a16="http://schemas.microsoft.com/office/drawing/2014/main" id="{003F984B-0A03-4E31-B202-AE2C7318F6DC}"/>
               </a:ext>
             </a:extLst>
           </p:cNvPr>
@@ -5244,7 +5244,7 @@
     </p:spTree>
     <p:extLst>
       <p:ext uri="{BB962C8B-B14F-4D97-AF65-F5344CB8AC3E}">
-        <p14:creationId xmlns:p14="http://schemas.microsoft.com/office/powerpoint/2010/main" val="65386260"/>
+        <p14:creationId xmlns:p14="http://schemas.microsoft.com/office/powerpoint/2010/main" val="993517849"/>
       </p:ext>
     </p:extLst>
   </p:cSld>
@@ -5275,7 +5275,7 @@
           <p:cNvPr id="11" name="">
             <a:extLst xmlns:a="http://schemas.openxmlformats.org/drawingml/2006/main">
               <a:ext uri="{FF2B5EF4-FFF2-40B4-BE49-F238E27FC236}">
-                <a16:creationId xmlns:a16="http://schemas.microsoft.com/office/drawing/2014/main" id="{74B064E0-7B4C-4B8F-973C-07DAAB1ADF29}"/>
+                <a16:creationId xmlns:a16="http://schemas.microsoft.com/office/drawing/2014/main" id="{06AE68CA-091E-475C-A99A-6335CCBD3906}"/>
               </a:ext>
             </a:extLst>
           </p:cNvPr>
@@ -5332,7 +5332,7 @@
           <p:cNvPr id="2" name="">
             <a:extLst xmlns:a="http://schemas.openxmlformats.org/drawingml/2006/main">
               <a:ext uri="{FF2B5EF4-FFF2-40B4-BE49-F238E27FC236}">
-                <a16:creationId xmlns:a16="http://schemas.microsoft.com/office/drawing/2014/main" id="{D3139BAB-CE58-41D5-949D-C683E4A7EE98}"/>
+                <a16:creationId xmlns:a16="http://schemas.microsoft.com/office/drawing/2014/main" id="{DF7B3038-DEEC-46A6-B338-03275A46CB4C}"/>
               </a:ext>
             </a:extLst>
           </p:cNvPr>
@@ -5782,7 +5782,7 @@
           <p:cNvPr id="4" name="">
             <a:extLst xmlns:a="http://schemas.openxmlformats.org/drawingml/2006/main">
               <a:ext uri="{FF2B5EF4-FFF2-40B4-BE49-F238E27FC236}">
-                <a16:creationId xmlns:a16="http://schemas.microsoft.com/office/drawing/2014/main" id="{809918CB-10A9-4F39-828B-F3D2607FDF34}"/>
+                <a16:creationId xmlns:a16="http://schemas.microsoft.com/office/drawing/2014/main" id="{29DCA95A-CA8B-4A31-A0AB-354CD9D43556}"/>
               </a:ext>
             </a:extLst>
           </p:cNvPr>
@@ -5862,7 +5862,7 @@
           <p:cNvPr id="5" name="">
             <a:extLst xmlns:a="http://schemas.openxmlformats.org/drawingml/2006/main">
               <a:ext uri="{FF2B5EF4-FFF2-40B4-BE49-F238E27FC236}">
-                <a16:creationId xmlns:a16="http://schemas.microsoft.com/office/drawing/2014/main" id="{57D02394-4447-4970-A73E-7FE68287FD8A}"/>
+                <a16:creationId xmlns:a16="http://schemas.microsoft.com/office/drawing/2014/main" id="{45E3B6AD-F9C5-47B6-976E-ED6431AB1ED8}"/>
               </a:ext>
             </a:extLst>
           </p:cNvPr>
@@ -6164,7 +6164,7 @@
           <p:cNvPr id="7" name="">
             <a:extLst xmlns:a="http://schemas.openxmlformats.org/drawingml/2006/main">
               <a:ext uri="{FF2B5EF4-FFF2-40B4-BE49-F238E27FC236}">
-                <a16:creationId xmlns:a16="http://schemas.microsoft.com/office/drawing/2014/main" id="{DD008A83-9CB2-4B4B-B6BB-A745A6374CA2}"/>
+                <a16:creationId xmlns:a16="http://schemas.microsoft.com/office/drawing/2014/main" id="{C2CE2DB5-1B0D-4EA6-944B-6DDD01D1BBB7}"/>
               </a:ext>
             </a:extLst>
           </p:cNvPr>
@@ -6244,7 +6244,7 @@
           <p:cNvPr id="8" name="">
             <a:extLst xmlns:a="http://schemas.openxmlformats.org/drawingml/2006/main">
               <a:ext uri="{FF2B5EF4-FFF2-40B4-BE49-F238E27FC236}">
-                <a16:creationId xmlns:a16="http://schemas.microsoft.com/office/drawing/2014/main" id="{BD0853B9-BB89-4B39-9828-0A1ECE9484BD}"/>
+                <a16:creationId xmlns:a16="http://schemas.microsoft.com/office/drawing/2014/main" id="{64AE5CA2-AFE0-4698-9672-9B1F536B5871}"/>
               </a:ext>
             </a:extLst>
           </p:cNvPr>
@@ -6301,7 +6301,7 @@
           <p:cNvPr id="9" name="">
             <a:extLst xmlns:a="http://schemas.openxmlformats.org/drawingml/2006/main">
               <a:ext uri="{FF2B5EF4-FFF2-40B4-BE49-F238E27FC236}">
-                <a16:creationId xmlns:a16="http://schemas.microsoft.com/office/drawing/2014/main" id="{A77657DB-9D73-4521-8C54-C01A2DE3F7B3}"/>
+                <a16:creationId xmlns:a16="http://schemas.microsoft.com/office/drawing/2014/main" id="{D8EE967F-A6EE-4A65-93D2-6856A4B8D922}"/>
               </a:ext>
             </a:extLst>
           </p:cNvPr>
@@ -6381,7 +6381,7 @@
           <p:cNvPr id="10" name="">
             <a:extLst xmlns:a="http://schemas.openxmlformats.org/drawingml/2006/main">
               <a:ext uri="{FF2B5EF4-FFF2-40B4-BE49-F238E27FC236}">
-                <a16:creationId xmlns:a16="http://schemas.microsoft.com/office/drawing/2014/main" id="{37FFA3FD-0EEA-43F6-B1A6-9E93D7E5F623}"/>
+                <a16:creationId xmlns:a16="http://schemas.microsoft.com/office/drawing/2014/main" id="{BF2AFEDE-2CB4-4BD7-B2DA-3250CB84593E}"/>
               </a:ext>
             </a:extLst>
           </p:cNvPr>
@@ -6436,7 +6436,7 @@
     </p:spTree>
     <p:extLst>
       <p:ext uri="{BB962C8B-B14F-4D97-AF65-F5344CB8AC3E}">
-        <p14:creationId xmlns:p14="http://schemas.microsoft.com/office/powerpoint/2010/main" val="874484706"/>
+        <p14:creationId xmlns:p14="http://schemas.microsoft.com/office/powerpoint/2010/main" val="840271757"/>
       </p:ext>
     </p:extLst>
   </p:cSld>
@@ -6467,7 +6467,7 @@
           <p:cNvPr id="12" name="">
             <a:extLst xmlns:a="http://schemas.openxmlformats.org/drawingml/2006/main">
               <a:ext uri="{FF2B5EF4-FFF2-40B4-BE49-F238E27FC236}">
-                <a16:creationId xmlns:a16="http://schemas.microsoft.com/office/drawing/2014/main" id="{0AA1D078-91C7-4757-8D08-0BE3FDCBD6C3}"/>
+                <a16:creationId xmlns:a16="http://schemas.microsoft.com/office/drawing/2014/main" id="{FC2E365B-9662-4E4D-9881-0D53790B1603}"/>
               </a:ext>
             </a:extLst>
           </p:cNvPr>
@@ -6524,7 +6524,7 @@
           <p:cNvPr id="2" name="">
             <a:extLst xmlns:a="http://schemas.openxmlformats.org/drawingml/2006/main">
               <a:ext uri="{FF2B5EF4-FFF2-40B4-BE49-F238E27FC236}">
-                <a16:creationId xmlns:a16="http://schemas.microsoft.com/office/drawing/2014/main" id="{40263824-829F-4C06-9EA6-96CB9B3DA085}"/>
+                <a16:creationId xmlns:a16="http://schemas.microsoft.com/office/drawing/2014/main" id="{8A2DE5B1-4B44-461B-B413-84E53F6F0C7C}"/>
               </a:ext>
             </a:extLst>
           </p:cNvPr>
@@ -6581,7 +6581,7 @@
           <p:cNvPr id="3" name="">
             <a:extLst xmlns:a="http://schemas.openxmlformats.org/drawingml/2006/main">
               <a:ext uri="{FF2B5EF4-FFF2-40B4-BE49-F238E27FC236}">
-                <a16:creationId xmlns:a16="http://schemas.microsoft.com/office/drawing/2014/main" id="{3C73C8A0-18F9-41FD-9805-F0C54CD29024}"/>
+                <a16:creationId xmlns:a16="http://schemas.microsoft.com/office/drawing/2014/main" id="{808E3793-A4F1-4EFC-BCC2-B5D913B1A5B1}"/>
               </a:ext>
             </a:extLst>
           </p:cNvPr>
@@ -6638,7 +6638,7 @@
           <p:cNvPr id="4" name="">
             <a:extLst xmlns:a="http://schemas.openxmlformats.org/drawingml/2006/main">
               <a:ext uri="{FF2B5EF4-FFF2-40B4-BE49-F238E27FC236}">
-                <a16:creationId xmlns:a16="http://schemas.microsoft.com/office/drawing/2014/main" id="{CC12B5F8-A4EF-4829-9AF4-ECC3E3F41D65}"/>
+                <a16:creationId xmlns:a16="http://schemas.microsoft.com/office/drawing/2014/main" id="{95F20151-C339-437C-8C9B-93C5D0B4EB81}"/>
               </a:ext>
             </a:extLst>
           </p:cNvPr>
@@ -6718,7 +6718,7 @@
           <p:cNvPr id="5" name="">
             <a:extLst xmlns:a="http://schemas.openxmlformats.org/drawingml/2006/main">
               <a:ext uri="{FF2B5EF4-FFF2-40B4-BE49-F238E27FC236}">
-                <a16:creationId xmlns:a16="http://schemas.microsoft.com/office/drawing/2014/main" id="{CC3735B4-1956-4CCF-8268-7B85B52254ED}"/>
+                <a16:creationId xmlns:a16="http://schemas.microsoft.com/office/drawing/2014/main" id="{E4179205-7C8C-4BBE-9697-3A86ABD6E452}"/>
               </a:ext>
             </a:extLst>
           </p:cNvPr>
@@ -6775,7 +6775,7 @@
           <p:cNvPr id="6" name="">
             <a:extLst xmlns:a="http://schemas.openxmlformats.org/drawingml/2006/main">
               <a:ext uri="{FF2B5EF4-FFF2-40B4-BE49-F238E27FC236}">
-                <a16:creationId xmlns:a16="http://schemas.microsoft.com/office/drawing/2014/main" id="{AFEFB724-1003-451D-AAAC-31CEFAE1494F}"/>
+                <a16:creationId xmlns:a16="http://schemas.microsoft.com/office/drawing/2014/main" id="{1989908F-F49E-4611-A149-66E472A239AC}"/>
               </a:ext>
             </a:extLst>
           </p:cNvPr>
@@ -6855,7 +6855,7 @@
           <p:cNvPr id="7" name="">
             <a:extLst xmlns:a="http://schemas.openxmlformats.org/drawingml/2006/main">
               <a:ext uri="{FF2B5EF4-FFF2-40B4-BE49-F238E27FC236}">
-                <a16:creationId xmlns:a16="http://schemas.microsoft.com/office/drawing/2014/main" id="{51CC8146-D2BA-4FE3-BE1D-40693620D8CD}"/>
+                <a16:creationId xmlns:a16="http://schemas.microsoft.com/office/drawing/2014/main" id="{FC840876-98F7-4173-8983-5CAF16356A03}"/>
               </a:ext>
             </a:extLst>
           </p:cNvPr>
@@ -6912,7 +6912,7 @@
           <p:cNvPr id="8" name="">
             <a:extLst xmlns:a="http://schemas.openxmlformats.org/drawingml/2006/main">
               <a:ext uri="{FF2B5EF4-FFF2-40B4-BE49-F238E27FC236}">
-                <a16:creationId xmlns:a16="http://schemas.microsoft.com/office/drawing/2014/main" id="{A00A52F4-20B3-4DF3-A581-EDE15E7544DF}"/>
+                <a16:creationId xmlns:a16="http://schemas.microsoft.com/office/drawing/2014/main" id="{AA3B6373-7092-418D-AC96-237A90D80B1E}"/>
               </a:ext>
             </a:extLst>
           </p:cNvPr>
@@ -6969,7 +6969,7 @@
           <p:cNvPr id="9" name="">
             <a:extLst xmlns:a="http://schemas.openxmlformats.org/drawingml/2006/main">
               <a:ext uri="{FF2B5EF4-FFF2-40B4-BE49-F238E27FC236}">
-                <a16:creationId xmlns:a16="http://schemas.microsoft.com/office/drawing/2014/main" id="{E16502EB-274C-481D-ABDA-8EBBA3171660}"/>
+                <a16:creationId xmlns:a16="http://schemas.microsoft.com/office/drawing/2014/main" id="{920BCD85-79B1-4A7B-B6D2-94348CA8A8A9}"/>
               </a:ext>
             </a:extLst>
           </p:cNvPr>
@@ -7026,7 +7026,7 @@
           <p:cNvPr id="10" name="">
             <a:extLst xmlns:a="http://schemas.openxmlformats.org/drawingml/2006/main">
               <a:ext uri="{FF2B5EF4-FFF2-40B4-BE49-F238E27FC236}">
-                <a16:creationId xmlns:a16="http://schemas.microsoft.com/office/drawing/2014/main" id="{7FF2AA1C-F394-42A8-9238-B0EAE35C7773}"/>
+                <a16:creationId xmlns:a16="http://schemas.microsoft.com/office/drawing/2014/main" id="{8AD76A39-988B-4ECD-BBF0-50820029C63B}"/>
               </a:ext>
             </a:extLst>
           </p:cNvPr>
@@ -7139,7 +7139,7 @@
           <p:cNvPr id="11" name="">
             <a:extLst xmlns:a="http://schemas.openxmlformats.org/drawingml/2006/main">
               <a:ext uri="{FF2B5EF4-FFF2-40B4-BE49-F238E27FC236}">
-                <a16:creationId xmlns:a16="http://schemas.microsoft.com/office/drawing/2014/main" id="{314602D0-0F65-45F0-B7BA-A081088F927E}"/>
+                <a16:creationId xmlns:a16="http://schemas.microsoft.com/office/drawing/2014/main" id="{534014B1-C45E-431C-838A-3C7937CE7040}"/>
               </a:ext>
             </a:extLst>
           </p:cNvPr>
@@ -7194,7 +7194,7 @@
     </p:spTree>
     <p:extLst>
       <p:ext uri="{BB962C8B-B14F-4D97-AF65-F5344CB8AC3E}">
-        <p14:creationId xmlns:p14="http://schemas.microsoft.com/office/powerpoint/2010/main" val="1064430608"/>
+        <p14:creationId xmlns:p14="http://schemas.microsoft.com/office/powerpoint/2010/main" val="1169677976"/>
       </p:ext>
     </p:extLst>
   </p:cSld>
@@ -7225,7 +7225,7 @@
           <p:cNvPr id="12" name="">
             <a:extLst xmlns:a="http://schemas.openxmlformats.org/drawingml/2006/main">
               <a:ext uri="{FF2B5EF4-FFF2-40B4-BE49-F238E27FC236}">
-                <a16:creationId xmlns:a16="http://schemas.microsoft.com/office/drawing/2014/main" id="{2F2E946E-58EA-4F93-AED2-DA8AB2F58289}"/>
+                <a16:creationId xmlns:a16="http://schemas.microsoft.com/office/drawing/2014/main" id="{17CA725C-BA2F-49B2-85CE-7E247A55679C}"/>
               </a:ext>
             </a:extLst>
           </p:cNvPr>
@@ -7282,7 +7282,7 @@
           <p:cNvPr id="2" name="">
             <a:extLst xmlns:a="http://schemas.openxmlformats.org/drawingml/2006/main">
               <a:ext uri="{FF2B5EF4-FFF2-40B4-BE49-F238E27FC236}">
-                <a16:creationId xmlns:a16="http://schemas.microsoft.com/office/drawing/2014/main" id="{B786379F-4468-4979-ABEE-DEF19438E8AB}"/>
+                <a16:creationId xmlns:a16="http://schemas.microsoft.com/office/drawing/2014/main" id="{C79F2B80-E070-4762-B3E3-9064C2A3A407}"/>
               </a:ext>
             </a:extLst>
           </p:cNvPr>
@@ -7339,7 +7339,7 @@
           <p:cNvPr id="3" name="">
             <a:extLst xmlns:a="http://schemas.openxmlformats.org/drawingml/2006/main">
               <a:ext uri="{FF2B5EF4-FFF2-40B4-BE49-F238E27FC236}">
-                <a16:creationId xmlns:a16="http://schemas.microsoft.com/office/drawing/2014/main" id="{FA7BE10F-F5A5-4CEC-B6ED-AAD3F04AFAC1}"/>
+                <a16:creationId xmlns:a16="http://schemas.microsoft.com/office/drawing/2014/main" id="{A9E9CED4-29DE-4DFA-A815-E9E94BAFF34A}"/>
               </a:ext>
             </a:extLst>
           </p:cNvPr>
@@ -7396,7 +7396,7 @@
           <p:cNvPr id="4" name="">
             <a:extLst xmlns:a="http://schemas.openxmlformats.org/drawingml/2006/main">
               <a:ext uri="{FF2B5EF4-FFF2-40B4-BE49-F238E27FC236}">
-                <a16:creationId xmlns:a16="http://schemas.microsoft.com/office/drawing/2014/main" id="{2CF269A2-2EA6-4173-BEAD-F9F9863D0408}"/>
+                <a16:creationId xmlns:a16="http://schemas.microsoft.com/office/drawing/2014/main" id="{0ED11D88-0E38-46B0-AFA8-86C9E10F1AE0}"/>
               </a:ext>
             </a:extLst>
           </p:cNvPr>
@@ -7499,7 +7499,7 @@
           <p:cNvPr id="5" name="">
             <a:extLst xmlns:a="http://schemas.openxmlformats.org/drawingml/2006/main">
               <a:ext uri="{FF2B5EF4-FFF2-40B4-BE49-F238E27FC236}">
-                <a16:creationId xmlns:a16="http://schemas.microsoft.com/office/drawing/2014/main" id="{84BD5E62-51FA-463B-B64A-A9A6ADBEBB4C}"/>
+                <a16:creationId xmlns:a16="http://schemas.microsoft.com/office/drawing/2014/main" id="{A50660FF-6AFB-4EE0-9CCA-2FB03DDB5A97}"/>
               </a:ext>
             </a:extLst>
           </p:cNvPr>
@@ -7556,7 +7556,7 @@
           <p:cNvPr id="6" name="">
             <a:extLst xmlns:a="http://schemas.openxmlformats.org/drawingml/2006/main">
               <a:ext uri="{FF2B5EF4-FFF2-40B4-BE49-F238E27FC236}">
-                <a16:creationId xmlns:a16="http://schemas.microsoft.com/office/drawing/2014/main" id="{A2339D3F-678E-4563-8C9B-7E07E380F670}"/>
+                <a16:creationId xmlns:a16="http://schemas.microsoft.com/office/drawing/2014/main" id="{A8F097C8-6F1D-4D6C-9586-27F40BCA965B}"/>
               </a:ext>
             </a:extLst>
           </p:cNvPr>
@@ -7659,7 +7659,7 @@
           <p:cNvPr id="7" name="">
             <a:extLst xmlns:a="http://schemas.openxmlformats.org/drawingml/2006/main">
               <a:ext uri="{FF2B5EF4-FFF2-40B4-BE49-F238E27FC236}">
-                <a16:creationId xmlns:a16="http://schemas.microsoft.com/office/drawing/2014/main" id="{885F8A35-CDD0-40C3-9FD6-730B000F2F2E}"/>
+                <a16:creationId xmlns:a16="http://schemas.microsoft.com/office/drawing/2014/main" id="{8E9FAECD-7609-477D-A817-95F045CC6EDC}"/>
               </a:ext>
             </a:extLst>
           </p:cNvPr>
@@ -7716,7 +7716,7 @@
           <p:cNvPr id="8" name="">
             <a:extLst xmlns:a="http://schemas.openxmlformats.org/drawingml/2006/main">
               <a:ext uri="{FF2B5EF4-FFF2-40B4-BE49-F238E27FC236}">
-                <a16:creationId xmlns:a16="http://schemas.microsoft.com/office/drawing/2014/main" id="{6F6877E7-8678-4AE7-B1B0-6D3BF2715BAF}"/>
+                <a16:creationId xmlns:a16="http://schemas.microsoft.com/office/drawing/2014/main" id="{DD936E6A-052F-4704-9E4A-1EA6EDC747CC}"/>
               </a:ext>
             </a:extLst>
           </p:cNvPr>
@@ -7819,7 +7819,7 @@
           <p:cNvPr id="9" name="">
             <a:extLst xmlns:a="http://schemas.openxmlformats.org/drawingml/2006/main">
               <a:ext uri="{FF2B5EF4-FFF2-40B4-BE49-F238E27FC236}">
-                <a16:creationId xmlns:a16="http://schemas.microsoft.com/office/drawing/2014/main" id="{EEA89525-9122-470B-B345-DD69B39F9417}"/>
+                <a16:creationId xmlns:a16="http://schemas.microsoft.com/office/drawing/2014/main" id="{05E684AD-4098-49F8-9F80-2CF24C19C89D}"/>
               </a:ext>
             </a:extLst>
           </p:cNvPr>
@@ -7876,7 +7876,7 @@
           <p:cNvPr id="10" name="">
             <a:extLst xmlns:a="http://schemas.openxmlformats.org/drawingml/2006/main">
               <a:ext uri="{FF2B5EF4-FFF2-40B4-BE49-F238E27FC236}">
-                <a16:creationId xmlns:a16="http://schemas.microsoft.com/office/drawing/2014/main" id="{43E45430-DCA0-42DE-87C0-65BFAB2D103B}"/>
+                <a16:creationId xmlns:a16="http://schemas.microsoft.com/office/drawing/2014/main" id="{4B44DB00-D1B4-4A1F-B602-1A311F25E63C}"/>
               </a:ext>
             </a:extLst>
           </p:cNvPr>
@@ -7979,7 +7979,7 @@
           <p:cNvPr id="11" name="">
             <a:extLst xmlns:a="http://schemas.openxmlformats.org/drawingml/2006/main">
               <a:ext uri="{FF2B5EF4-FFF2-40B4-BE49-F238E27FC236}">
-                <a16:creationId xmlns:a16="http://schemas.microsoft.com/office/drawing/2014/main" id="{FC165F35-7F4D-4317-BFF1-78A3291F4451}"/>
+                <a16:creationId xmlns:a16="http://schemas.microsoft.com/office/drawing/2014/main" id="{EBF5C261-82F8-427B-9658-0140F8FC6686}"/>
               </a:ext>
             </a:extLst>
           </p:cNvPr>
@@ -8034,7 +8034,7 @@
     </p:spTree>
     <p:extLst>
       <p:ext uri="{BB962C8B-B14F-4D97-AF65-F5344CB8AC3E}">
-        <p14:creationId xmlns:p14="http://schemas.microsoft.com/office/powerpoint/2010/main" val="1503161985"/>
+        <p14:creationId xmlns:p14="http://schemas.microsoft.com/office/powerpoint/2010/main" val="1330127063"/>
       </p:ext>
     </p:extLst>
   </p:cSld>
@@ -8065,7 +8065,7 @@
           <p:cNvPr id="5" name="">
             <a:extLst xmlns:a="http://schemas.openxmlformats.org/drawingml/2006/main">
               <a:ext uri="{FF2B5EF4-FFF2-40B4-BE49-F238E27FC236}">
-                <a16:creationId xmlns:a16="http://schemas.microsoft.com/office/drawing/2014/main" id="{5A1552F2-67CB-45A8-A751-40B661AA608A}"/>
+                <a16:creationId xmlns:a16="http://schemas.microsoft.com/office/drawing/2014/main" id="{9BF38EA7-E990-45B7-B998-B3C784558FC7}"/>
               </a:ext>
             </a:extLst>
           </p:cNvPr>
@@ -8199,7 +8199,7 @@
                           <a:ea typeface="Microsoft YaHei"/>
                           <a:cs typeface="Microsoft YaHei"/>
                         </a:rPr>
-                        <a:t>计划占比</a:t>
+                        <a:t>工作量占比</a:t>
                       </a:r>
                     </a:p>
                   </a:txBody>
@@ -8663,7 +8663,7 @@
           <p:cNvPr id="3" name="">
             <a:extLst xmlns:a="http://schemas.openxmlformats.org/drawingml/2006/main">
               <a:ext uri="{FF2B5EF4-FFF2-40B4-BE49-F238E27FC236}">
-                <a16:creationId xmlns:a16="http://schemas.microsoft.com/office/drawing/2014/main" id="{3E5E35F7-521F-4B00-ACA9-A98CE1CF3A35}"/>
+                <a16:creationId xmlns:a16="http://schemas.microsoft.com/office/drawing/2014/main" id="{AEFE12F3-6492-4DB4-AF38-6C2176F97068}"/>
               </a:ext>
             </a:extLst>
           </p:cNvPr>
@@ -8710,7 +8710,7 @@
                 <a:ea typeface="Microsoft YaHei"/>
                 <a:cs typeface="Microsoft YaHei"/>
               </a:rPr>
-              <a:t>实际贡献以成员工作记录和共同确认为准</a:t>
+              <a:t>工作量占比按组长确认的分配填写，合计 100%</a:t>
             </a:r>
           </a:p>
         </p:txBody>
@@ -8720,7 +8720,7 @@
           <p:cNvPr id="4" name="">
             <a:extLst xmlns:a="http://schemas.openxmlformats.org/drawingml/2006/main">
               <a:ext uri="{FF2B5EF4-FFF2-40B4-BE49-F238E27FC236}">
-                <a16:creationId xmlns:a16="http://schemas.microsoft.com/office/drawing/2014/main" id="{C950632A-9A5A-445B-9BC7-0F04E0A63FA5}"/>
+                <a16:creationId xmlns:a16="http://schemas.microsoft.com/office/drawing/2014/main" id="{B3392A1E-5AED-48D3-B71A-2B0CE8B84626}"/>
               </a:ext>
             </a:extLst>
           </p:cNvPr>
@@ -8775,7 +8775,7 @@
     </p:spTree>
     <p:extLst>
       <p:ext uri="{BB962C8B-B14F-4D97-AF65-F5344CB8AC3E}">
-        <p14:creationId xmlns:p14="http://schemas.microsoft.com/office/powerpoint/2010/main" val="1209485702"/>
+        <p14:creationId xmlns:p14="http://schemas.microsoft.com/office/powerpoint/2010/main" val="1511889257"/>
       </p:ext>
     </p:extLst>
   </p:cSld>
@@ -8806,7 +8806,7 @@
           <p:cNvPr id="5" name="">
             <a:extLst xmlns:a="http://schemas.openxmlformats.org/drawingml/2006/main">
               <a:ext uri="{FF2B5EF4-FFF2-40B4-BE49-F238E27FC236}">
-                <a16:creationId xmlns:a16="http://schemas.microsoft.com/office/drawing/2014/main" id="{8B4AFFB4-8D18-486E-914F-1EC6B561CFA6}"/>
+                <a16:creationId xmlns:a16="http://schemas.microsoft.com/office/drawing/2014/main" id="{5A1FED87-F6C4-4F15-9F83-E3062A5CF48B}"/>
               </a:ext>
             </a:extLst>
           </p:cNvPr>
@@ -9360,7 +9360,7 @@
           <p:cNvPr id="3" name="">
             <a:extLst xmlns:a="http://schemas.openxmlformats.org/drawingml/2006/main">
               <a:ext uri="{FF2B5EF4-FFF2-40B4-BE49-F238E27FC236}">
-                <a16:creationId xmlns:a16="http://schemas.microsoft.com/office/drawing/2014/main" id="{304BBC20-AD69-466C-963D-138AB6E571CC}"/>
+                <a16:creationId xmlns:a16="http://schemas.microsoft.com/office/drawing/2014/main" id="{D6537021-CB73-4F9D-BA03-776CA4A21545}"/>
               </a:ext>
             </a:extLst>
           </p:cNvPr>
@@ -9417,7 +9417,7 @@
           <p:cNvPr id="4" name="">
             <a:extLst xmlns:a="http://schemas.openxmlformats.org/drawingml/2006/main">
               <a:ext uri="{FF2B5EF4-FFF2-40B4-BE49-F238E27FC236}">
-                <a16:creationId xmlns:a16="http://schemas.microsoft.com/office/drawing/2014/main" id="{4FCAA420-91D1-4433-845A-865FC6AA5DF4}"/>
+                <a16:creationId xmlns:a16="http://schemas.microsoft.com/office/drawing/2014/main" id="{7FE44E40-9C59-4F20-B180-06A8FFFB9A26}"/>
               </a:ext>
             </a:extLst>
           </p:cNvPr>
@@ -9472,7 +9472,7 @@
     </p:spTree>
     <p:extLst>
       <p:ext uri="{BB962C8B-B14F-4D97-AF65-F5344CB8AC3E}">
-        <p14:creationId xmlns:p14="http://schemas.microsoft.com/office/powerpoint/2010/main" val="645010031"/>
+        <p14:creationId xmlns:p14="http://schemas.microsoft.com/office/powerpoint/2010/main" val="124752164"/>
       </p:ext>
     </p:extLst>
   </p:cSld>
@@ -9503,7 +9503,7 @@
           <p:cNvPr id="10" name="">
             <a:extLst xmlns:a="http://schemas.openxmlformats.org/drawingml/2006/main">
               <a:ext uri="{FF2B5EF4-FFF2-40B4-BE49-F238E27FC236}">
-                <a16:creationId xmlns:a16="http://schemas.microsoft.com/office/drawing/2014/main" id="{74762244-1188-4374-AAD2-C2E2EAEBEAAD}"/>
+                <a16:creationId xmlns:a16="http://schemas.microsoft.com/office/drawing/2014/main" id="{8549E66C-AC04-445E-9CFE-F36030B86937}"/>
               </a:ext>
             </a:extLst>
           </p:cNvPr>
@@ -9564,7 +9564,7 @@
           <p:nvPr/>
         </p:nvPicPr>
         <p:blipFill>
-          <a:blip xmlns:r="http://schemas.openxmlformats.org/officeDocument/2006/relationships" xmlns:a="http://schemas.openxmlformats.org/drawingml/2006/main" r:embed="R14f6d3547e08429b"/>
+          <a:blip xmlns:r="http://schemas.openxmlformats.org/officeDocument/2006/relationships" xmlns:a="http://schemas.openxmlformats.org/drawingml/2006/main" r:embed="R2c3eeec9cdcf4e24"/>
           <a:stretch xmlns:a="http://schemas.openxmlformats.org/drawingml/2006/main"/>
         </p:blipFill>
         <p:spPr>
@@ -9582,7 +9582,7 @@
           <p:cNvPr id="3" name="">
             <a:extLst xmlns:a="http://schemas.openxmlformats.org/drawingml/2006/main">
               <a:ext uri="{FF2B5EF4-FFF2-40B4-BE49-F238E27FC236}">
-                <a16:creationId xmlns:a16="http://schemas.microsoft.com/office/drawing/2014/main" id="{5356A250-9DD9-45E8-88F5-13FBE90E9B3E}"/>
+                <a16:creationId xmlns:a16="http://schemas.microsoft.com/office/drawing/2014/main" id="{EF27F4C0-051C-41A6-8C2B-D00933C04846}"/>
               </a:ext>
             </a:extLst>
           </p:cNvPr>
@@ -9639,7 +9639,7 @@
           <p:cNvPr id="4" name="">
             <a:extLst xmlns:a="http://schemas.openxmlformats.org/drawingml/2006/main">
               <a:ext uri="{FF2B5EF4-FFF2-40B4-BE49-F238E27FC236}">
-                <a16:creationId xmlns:a16="http://schemas.microsoft.com/office/drawing/2014/main" id="{972C6958-FAC6-490E-A31A-2A76D41A988A}"/>
+                <a16:creationId xmlns:a16="http://schemas.microsoft.com/office/drawing/2014/main" id="{8A4CDBCC-71C8-4F2B-9414-5487D1B1E7BB}"/>
               </a:ext>
             </a:extLst>
           </p:cNvPr>
@@ -9742,7 +9742,7 @@
           <p:cNvPr id="5" name="">
             <a:extLst xmlns:a="http://schemas.openxmlformats.org/drawingml/2006/main">
               <a:ext uri="{FF2B5EF4-FFF2-40B4-BE49-F238E27FC236}">
-                <a16:creationId xmlns:a16="http://schemas.microsoft.com/office/drawing/2014/main" id="{171130B4-4204-4944-803B-691AA21BF96E}"/>
+                <a16:creationId xmlns:a16="http://schemas.microsoft.com/office/drawing/2014/main" id="{CF79022A-FF2E-4FAE-BB14-40FF71968FA1}"/>
               </a:ext>
             </a:extLst>
           </p:cNvPr>
@@ -9799,7 +9799,7 @@
           <p:cNvPr id="6" name="">
             <a:extLst xmlns:a="http://schemas.openxmlformats.org/drawingml/2006/main">
               <a:ext uri="{FF2B5EF4-FFF2-40B4-BE49-F238E27FC236}">
-                <a16:creationId xmlns:a16="http://schemas.microsoft.com/office/drawing/2014/main" id="{6770F7FE-A459-42DE-9E9F-CF32DCF005C9}"/>
+                <a16:creationId xmlns:a16="http://schemas.microsoft.com/office/drawing/2014/main" id="{DDA9C6F4-8690-4237-8DA5-02BFACC065FB}"/>
               </a:ext>
             </a:extLst>
           </p:cNvPr>
@@ -9902,7 +9902,7 @@
           <p:cNvPr id="7" name="">
             <a:extLst xmlns:a="http://schemas.openxmlformats.org/drawingml/2006/main">
               <a:ext uri="{FF2B5EF4-FFF2-40B4-BE49-F238E27FC236}">
-                <a16:creationId xmlns:a16="http://schemas.microsoft.com/office/drawing/2014/main" id="{198EBF06-7E48-4DA5-96F4-125EA9976AB2}"/>
+                <a16:creationId xmlns:a16="http://schemas.microsoft.com/office/drawing/2014/main" id="{443662E7-3A3B-466F-A2B8-81915C4C0EB3}"/>
               </a:ext>
             </a:extLst>
           </p:cNvPr>
@@ -9959,7 +9959,7 @@
           <p:cNvPr id="8" name="">
             <a:extLst xmlns:a="http://schemas.openxmlformats.org/drawingml/2006/main">
               <a:ext uri="{FF2B5EF4-FFF2-40B4-BE49-F238E27FC236}">
-                <a16:creationId xmlns:a16="http://schemas.microsoft.com/office/drawing/2014/main" id="{387629EC-75A5-4095-827A-A608CC744687}"/>
+                <a16:creationId xmlns:a16="http://schemas.microsoft.com/office/drawing/2014/main" id="{E27212E2-604D-4DB2-9E48-A0CC98A73D03}"/>
               </a:ext>
             </a:extLst>
           </p:cNvPr>
@@ -10062,7 +10062,7 @@
           <p:cNvPr id="9" name="">
             <a:extLst xmlns:a="http://schemas.openxmlformats.org/drawingml/2006/main">
               <a:ext uri="{FF2B5EF4-FFF2-40B4-BE49-F238E27FC236}">
-                <a16:creationId xmlns:a16="http://schemas.microsoft.com/office/drawing/2014/main" id="{D2997FA7-1241-4CFE-A7DC-CE3852640E3E}"/>
+                <a16:creationId xmlns:a16="http://schemas.microsoft.com/office/drawing/2014/main" id="{99A5BF55-F9ED-4CE9-A100-CFDF6BCEBB04}"/>
               </a:ext>
             </a:extLst>
           </p:cNvPr>
@@ -10117,7 +10117,7 @@
     </p:spTree>
     <p:extLst>
       <p:ext uri="{BB962C8B-B14F-4D97-AF65-F5344CB8AC3E}">
-        <p14:creationId xmlns:p14="http://schemas.microsoft.com/office/powerpoint/2010/main" val="130884051"/>
+        <p14:creationId xmlns:p14="http://schemas.microsoft.com/office/powerpoint/2010/main" val="530019461"/>
       </p:ext>
     </p:extLst>
   </p:cSld>
@@ -10148,7 +10148,7 @@
           <p:cNvPr id="10" name="">
             <a:extLst xmlns:a="http://schemas.openxmlformats.org/drawingml/2006/main">
               <a:ext uri="{FF2B5EF4-FFF2-40B4-BE49-F238E27FC236}">
-                <a16:creationId xmlns:a16="http://schemas.microsoft.com/office/drawing/2014/main" id="{296CE2A9-BDB8-44AF-8B07-A9E0B4344DE6}"/>
+                <a16:creationId xmlns:a16="http://schemas.microsoft.com/office/drawing/2014/main" id="{F589AD07-1598-4B5D-988F-5900170F2550}"/>
               </a:ext>
             </a:extLst>
           </p:cNvPr>
@@ -10209,7 +10209,7 @@
           <p:nvPr/>
         </p:nvPicPr>
         <p:blipFill>
-          <a:blip xmlns:r="http://schemas.openxmlformats.org/officeDocument/2006/relationships" xmlns:a="http://schemas.openxmlformats.org/drawingml/2006/main" r:embed="Rb6f6226a5a6a4b8a"/>
+          <a:blip xmlns:r="http://schemas.openxmlformats.org/officeDocument/2006/relationships" xmlns:a="http://schemas.openxmlformats.org/drawingml/2006/main" r:embed="Rb004508783d54b64"/>
           <a:stretch xmlns:a="http://schemas.openxmlformats.org/drawingml/2006/main"/>
         </p:blipFill>
         <p:spPr>
@@ -10227,7 +10227,7 @@
           <p:cNvPr id="3" name="">
             <a:extLst xmlns:a="http://schemas.openxmlformats.org/drawingml/2006/main">
               <a:ext uri="{FF2B5EF4-FFF2-40B4-BE49-F238E27FC236}">
-                <a16:creationId xmlns:a16="http://schemas.microsoft.com/office/drawing/2014/main" id="{3C32150D-5E63-427C-9FD9-91B5B8B6747A}"/>
+                <a16:creationId xmlns:a16="http://schemas.microsoft.com/office/drawing/2014/main" id="{D6233E19-A9BB-4CD9-BCBC-3C8DC08273C3}"/>
               </a:ext>
             </a:extLst>
           </p:cNvPr>
@@ -10284,7 +10284,7 @@
           <p:cNvPr id="4" name="">
             <a:extLst xmlns:a="http://schemas.openxmlformats.org/drawingml/2006/main">
               <a:ext uri="{FF2B5EF4-FFF2-40B4-BE49-F238E27FC236}">
-                <a16:creationId xmlns:a16="http://schemas.microsoft.com/office/drawing/2014/main" id="{2B96118B-D7C1-4A12-B11B-74D1BB73F76B}"/>
+                <a16:creationId xmlns:a16="http://schemas.microsoft.com/office/drawing/2014/main" id="{EBD467D8-C337-4D20-8839-BE3C6185FC9D}"/>
               </a:ext>
             </a:extLst>
           </p:cNvPr>
@@ -10387,7 +10387,7 @@
           <p:cNvPr id="5" name="">
             <a:extLst xmlns:a="http://schemas.openxmlformats.org/drawingml/2006/main">
               <a:ext uri="{FF2B5EF4-FFF2-40B4-BE49-F238E27FC236}">
-                <a16:creationId xmlns:a16="http://schemas.microsoft.com/office/drawing/2014/main" id="{312FB914-CFD8-4B81-9F0D-0C2F255E9AA5}"/>
+                <a16:creationId xmlns:a16="http://schemas.microsoft.com/office/drawing/2014/main" id="{E23A0FF3-2CF8-47C0-A62A-95DD1A6E3489}"/>
               </a:ext>
             </a:extLst>
           </p:cNvPr>
@@ -10444,7 +10444,7 @@
           <p:cNvPr id="6" name="">
             <a:extLst xmlns:a="http://schemas.openxmlformats.org/drawingml/2006/main">
               <a:ext uri="{FF2B5EF4-FFF2-40B4-BE49-F238E27FC236}">
-                <a16:creationId xmlns:a16="http://schemas.microsoft.com/office/drawing/2014/main" id="{7D5B45B3-D106-47A0-91C6-1595828D8C93}"/>
+                <a16:creationId xmlns:a16="http://schemas.microsoft.com/office/drawing/2014/main" id="{894BCEB5-CBF5-492C-B1B8-47E9F25BB6CC}"/>
               </a:ext>
             </a:extLst>
           </p:cNvPr>
@@ -10547,7 +10547,7 @@
           <p:cNvPr id="7" name="">
             <a:extLst xmlns:a="http://schemas.openxmlformats.org/drawingml/2006/main">
               <a:ext uri="{FF2B5EF4-FFF2-40B4-BE49-F238E27FC236}">
-                <a16:creationId xmlns:a16="http://schemas.microsoft.com/office/drawing/2014/main" id="{CF444A82-AAD6-4696-B179-7E35C7E1351F}"/>
+                <a16:creationId xmlns:a16="http://schemas.microsoft.com/office/drawing/2014/main" id="{C39DFC37-12A1-4C65-98D4-8B77E086AFC0}"/>
               </a:ext>
             </a:extLst>
           </p:cNvPr>
@@ -10604,7 +10604,7 @@
           <p:cNvPr id="8" name="">
             <a:extLst xmlns:a="http://schemas.openxmlformats.org/drawingml/2006/main">
               <a:ext uri="{FF2B5EF4-FFF2-40B4-BE49-F238E27FC236}">
-                <a16:creationId xmlns:a16="http://schemas.microsoft.com/office/drawing/2014/main" id="{7BE1ACEA-4BC7-4ABE-AFE5-E71BF2E6C532}"/>
+                <a16:creationId xmlns:a16="http://schemas.microsoft.com/office/drawing/2014/main" id="{B0ACA413-1418-4AF3-8583-D9A1A063B8FB}"/>
               </a:ext>
             </a:extLst>
           </p:cNvPr>
@@ -10707,7 +10707,7 @@
           <p:cNvPr id="9" name="">
             <a:extLst xmlns:a="http://schemas.openxmlformats.org/drawingml/2006/main">
               <a:ext uri="{FF2B5EF4-FFF2-40B4-BE49-F238E27FC236}">
-                <a16:creationId xmlns:a16="http://schemas.microsoft.com/office/drawing/2014/main" id="{66E2B5D6-FDA5-4F3B-840E-F83A03F37444}"/>
+                <a16:creationId xmlns:a16="http://schemas.microsoft.com/office/drawing/2014/main" id="{995524C7-1FC7-45AE-ADF6-5CF14A65A502}"/>
               </a:ext>
             </a:extLst>
           </p:cNvPr>
@@ -10762,7 +10762,7 @@
     </p:spTree>
     <p:extLst>
       <p:ext uri="{BB962C8B-B14F-4D97-AF65-F5344CB8AC3E}">
-        <p14:creationId xmlns:p14="http://schemas.microsoft.com/office/powerpoint/2010/main" val="189304661"/>
+        <p14:creationId xmlns:p14="http://schemas.microsoft.com/office/powerpoint/2010/main" val="1425801623"/>
       </p:ext>
     </p:extLst>
   </p:cSld>
@@ -10793,7 +10793,7 @@
           <p:cNvPr id="10" name="">
             <a:extLst xmlns:a="http://schemas.openxmlformats.org/drawingml/2006/main">
               <a:ext uri="{FF2B5EF4-FFF2-40B4-BE49-F238E27FC236}">
-                <a16:creationId xmlns:a16="http://schemas.microsoft.com/office/drawing/2014/main" id="{2264AA28-3EEC-4033-A290-690D0AAEBBC8}"/>
+                <a16:creationId xmlns:a16="http://schemas.microsoft.com/office/drawing/2014/main" id="{7ADEE588-66D3-4134-958E-7A107D7AE72E}"/>
               </a:ext>
             </a:extLst>
           </p:cNvPr>
@@ -10850,7 +10850,7 @@
           <p:cNvPr id="2" name="">
             <a:extLst xmlns:a="http://schemas.openxmlformats.org/drawingml/2006/main">
               <a:ext uri="{FF2B5EF4-FFF2-40B4-BE49-F238E27FC236}">
-                <a16:creationId xmlns:a16="http://schemas.microsoft.com/office/drawing/2014/main" id="{B2CE2222-2058-432D-9949-5C539BB496D1}"/>
+                <a16:creationId xmlns:a16="http://schemas.microsoft.com/office/drawing/2014/main" id="{BFCA00B3-2275-49D4-B163-54629C03AFE4}"/>
               </a:ext>
             </a:extLst>
           </p:cNvPr>
@@ -10907,7 +10907,7 @@
           <p:cNvPr id="3" name="">
             <a:extLst xmlns:a="http://schemas.openxmlformats.org/drawingml/2006/main">
               <a:ext uri="{FF2B5EF4-FFF2-40B4-BE49-F238E27FC236}">
-                <a16:creationId xmlns:a16="http://schemas.microsoft.com/office/drawing/2014/main" id="{8EBE5B74-4F84-4D04-99FC-F6EF3E38943D}"/>
+                <a16:creationId xmlns:a16="http://schemas.microsoft.com/office/drawing/2014/main" id="{1612C6CB-D595-4AD6-B810-D088E19ADC65}"/>
               </a:ext>
             </a:extLst>
           </p:cNvPr>
@@ -11010,7 +11010,7 @@
           <p:cNvPr id="4" name="">
             <a:extLst xmlns:a="http://schemas.openxmlformats.org/drawingml/2006/main">
               <a:ext uri="{FF2B5EF4-FFF2-40B4-BE49-F238E27FC236}">
-                <a16:creationId xmlns:a16="http://schemas.microsoft.com/office/drawing/2014/main" id="{B2C53E7D-91BD-493E-AF0B-F4F2F491E877}"/>
+                <a16:creationId xmlns:a16="http://schemas.microsoft.com/office/drawing/2014/main" id="{E7626123-4E23-44D6-A38A-6A020C797A98}"/>
               </a:ext>
             </a:extLst>
           </p:cNvPr>
@@ -11067,7 +11067,7 @@
           <p:cNvPr id="5" name="">
             <a:extLst xmlns:a="http://schemas.openxmlformats.org/drawingml/2006/main">
               <a:ext uri="{FF2B5EF4-FFF2-40B4-BE49-F238E27FC236}">
-                <a16:creationId xmlns:a16="http://schemas.microsoft.com/office/drawing/2014/main" id="{4C774663-5BC5-49C2-AAE7-4AA80EBAD202}"/>
+                <a16:creationId xmlns:a16="http://schemas.microsoft.com/office/drawing/2014/main" id="{ECADAC43-1C3B-4D1C-A8EA-C0EBEB372477}"/>
               </a:ext>
             </a:extLst>
           </p:cNvPr>
@@ -11170,7 +11170,7 @@
           <p:cNvPr id="6" name="">
             <a:extLst xmlns:a="http://schemas.openxmlformats.org/drawingml/2006/main">
               <a:ext uri="{FF2B5EF4-FFF2-40B4-BE49-F238E27FC236}">
-                <a16:creationId xmlns:a16="http://schemas.microsoft.com/office/drawing/2014/main" id="{88B5A7A5-C97D-4A15-BB3E-24979FDDD1A3}"/>
+                <a16:creationId xmlns:a16="http://schemas.microsoft.com/office/drawing/2014/main" id="{10BA9435-8F50-4298-A998-C825A8A59938}"/>
               </a:ext>
             </a:extLst>
           </p:cNvPr>
@@ -11227,7 +11227,7 @@
           <p:cNvPr id="7" name="">
             <a:extLst xmlns:a="http://schemas.openxmlformats.org/drawingml/2006/main">
               <a:ext uri="{FF2B5EF4-FFF2-40B4-BE49-F238E27FC236}">
-                <a16:creationId xmlns:a16="http://schemas.microsoft.com/office/drawing/2014/main" id="{FE26DF84-C80F-4845-9F57-6D33372435E8}"/>
+                <a16:creationId xmlns:a16="http://schemas.microsoft.com/office/drawing/2014/main" id="{87C6391D-A6BB-4FA7-9CBC-CBC098CE8B2B}"/>
               </a:ext>
             </a:extLst>
           </p:cNvPr>
@@ -11334,7 +11334,7 @@
           <p:nvPr/>
         </p:nvPicPr>
         <p:blipFill>
-          <a:blip xmlns:r="http://schemas.openxmlformats.org/officeDocument/2006/relationships" xmlns:a="http://schemas.openxmlformats.org/drawingml/2006/main" r:embed="Rf2b90ef72d204aa0"/>
+          <a:blip xmlns:r="http://schemas.openxmlformats.org/officeDocument/2006/relationships" xmlns:a="http://schemas.openxmlformats.org/drawingml/2006/main" r:embed="R6a735ce3f2a74ae7"/>
           <a:stretch xmlns:a="http://schemas.openxmlformats.org/drawingml/2006/main"/>
         </p:blipFill>
         <p:spPr>
@@ -11352,7 +11352,7 @@
           <p:cNvPr id="9" name="">
             <a:extLst xmlns:a="http://schemas.openxmlformats.org/drawingml/2006/main">
               <a:ext uri="{FF2B5EF4-FFF2-40B4-BE49-F238E27FC236}">
-                <a16:creationId xmlns:a16="http://schemas.microsoft.com/office/drawing/2014/main" id="{E26FFE29-6115-4382-B534-BC73D9855A10}"/>
+                <a16:creationId xmlns:a16="http://schemas.microsoft.com/office/drawing/2014/main" id="{9A36167E-4750-42DD-BAD6-C21B6AED5CDD}"/>
               </a:ext>
             </a:extLst>
           </p:cNvPr>
@@ -11407,7 +11407,7 @@
     </p:spTree>
     <p:extLst>
       <p:ext uri="{BB962C8B-B14F-4D97-AF65-F5344CB8AC3E}">
-        <p14:creationId xmlns:p14="http://schemas.microsoft.com/office/powerpoint/2010/main" val="1448765877"/>
+        <p14:creationId xmlns:p14="http://schemas.microsoft.com/office/powerpoint/2010/main" val="1044768233"/>
       </p:ext>
     </p:extLst>
   </p:cSld>
@@ -11438,7 +11438,7 @@
           <p:cNvPr id="5" name="">
             <a:extLst xmlns:a="http://schemas.openxmlformats.org/drawingml/2006/main">
               <a:ext uri="{FF2B5EF4-FFF2-40B4-BE49-F238E27FC236}">
-                <a16:creationId xmlns:a16="http://schemas.microsoft.com/office/drawing/2014/main" id="{B8EB6FE6-4267-4607-A04E-4BC38E4D7616}"/>
+                <a16:creationId xmlns:a16="http://schemas.microsoft.com/office/drawing/2014/main" id="{0DF87848-D4CE-49D7-A6C5-6DFA58B1EEAB}"/>
               </a:ext>
             </a:extLst>
           </p:cNvPr>
@@ -12092,7 +12092,7 @@
           <p:cNvPr id="3" name="">
             <a:extLst xmlns:a="http://schemas.openxmlformats.org/drawingml/2006/main">
               <a:ext uri="{FF2B5EF4-FFF2-40B4-BE49-F238E27FC236}">
-                <a16:creationId xmlns:a16="http://schemas.microsoft.com/office/drawing/2014/main" id="{157A30E9-E830-4C4D-8475-5DEB1955EB18}"/>
+                <a16:creationId xmlns:a16="http://schemas.microsoft.com/office/drawing/2014/main" id="{71F5E086-AFA7-407F-B685-1EC00637B2A5}"/>
               </a:ext>
             </a:extLst>
           </p:cNvPr>
@@ -12149,7 +12149,7 @@
           <p:cNvPr id="4" name="">
             <a:extLst xmlns:a="http://schemas.openxmlformats.org/drawingml/2006/main">
               <a:ext uri="{FF2B5EF4-FFF2-40B4-BE49-F238E27FC236}">
-                <a16:creationId xmlns:a16="http://schemas.microsoft.com/office/drawing/2014/main" id="{7C2A04AA-EA7B-4F1D-A083-277D170E2692}"/>
+                <a16:creationId xmlns:a16="http://schemas.microsoft.com/office/drawing/2014/main" id="{481C896A-2569-4AE5-A25A-343AFF1744DE}"/>
               </a:ext>
             </a:extLst>
           </p:cNvPr>
@@ -12204,7 +12204,7 @@
     </p:spTree>
     <p:extLst>
       <p:ext uri="{BB962C8B-B14F-4D97-AF65-F5344CB8AC3E}">
-        <p14:creationId xmlns:p14="http://schemas.microsoft.com/office/powerpoint/2010/main" val="1313306406"/>
+        <p14:creationId xmlns:p14="http://schemas.microsoft.com/office/powerpoint/2010/main" val="196573378"/>
       </p:ext>
     </p:extLst>
   </p:cSld>
@@ -12235,7 +12235,7 @@
           <p:cNvPr id="10" name="">
             <a:extLst xmlns:a="http://schemas.openxmlformats.org/drawingml/2006/main">
               <a:ext uri="{FF2B5EF4-FFF2-40B4-BE49-F238E27FC236}">
-                <a16:creationId xmlns:a16="http://schemas.microsoft.com/office/drawing/2014/main" id="{A6F5410D-FB36-4AAC-886A-8A68420D12B3}"/>
+                <a16:creationId xmlns:a16="http://schemas.microsoft.com/office/drawing/2014/main" id="{68AD770C-C8DA-4403-B236-C5EAB0176A26}"/>
               </a:ext>
             </a:extLst>
           </p:cNvPr>
@@ -12296,7 +12296,7 @@
           <p:nvPr/>
         </p:nvPicPr>
         <p:blipFill>
-          <a:blip xmlns:r="http://schemas.openxmlformats.org/officeDocument/2006/relationships" xmlns:a="http://schemas.openxmlformats.org/drawingml/2006/main" r:embed="Rbe39918d203e49ca"/>
+          <a:blip xmlns:r="http://schemas.openxmlformats.org/officeDocument/2006/relationships" xmlns:a="http://schemas.openxmlformats.org/drawingml/2006/main" r:embed="R12eff1c1f040483a"/>
           <a:stretch xmlns:a="http://schemas.openxmlformats.org/drawingml/2006/main"/>
         </p:blipFill>
         <p:spPr>
@@ -12314,7 +12314,7 @@
           <p:cNvPr id="3" name="">
             <a:extLst xmlns:a="http://schemas.openxmlformats.org/drawingml/2006/main">
               <a:ext uri="{FF2B5EF4-FFF2-40B4-BE49-F238E27FC236}">
-                <a16:creationId xmlns:a16="http://schemas.microsoft.com/office/drawing/2014/main" id="{8933175E-9F59-46F5-BA2B-D666888EA95B}"/>
+                <a16:creationId xmlns:a16="http://schemas.microsoft.com/office/drawing/2014/main" id="{8BAFB661-BCEC-460F-8AFA-F6002F93E89E}"/>
               </a:ext>
             </a:extLst>
           </p:cNvPr>
@@ -12371,7 +12371,7 @@
           <p:cNvPr id="4" name="">
             <a:extLst xmlns:a="http://schemas.openxmlformats.org/drawingml/2006/main">
               <a:ext uri="{FF2B5EF4-FFF2-40B4-BE49-F238E27FC236}">
-                <a16:creationId xmlns:a16="http://schemas.microsoft.com/office/drawing/2014/main" id="{3C49156B-6BA0-4622-BD4E-3C69871357FE}"/>
+                <a16:creationId xmlns:a16="http://schemas.microsoft.com/office/drawing/2014/main" id="{2E3151C1-F78C-4C35-BF7F-72BD2C592186}"/>
               </a:ext>
             </a:extLst>
           </p:cNvPr>
@@ -12474,7 +12474,7 @@
           <p:cNvPr id="5" name="">
             <a:extLst xmlns:a="http://schemas.openxmlformats.org/drawingml/2006/main">
               <a:ext uri="{FF2B5EF4-FFF2-40B4-BE49-F238E27FC236}">
-                <a16:creationId xmlns:a16="http://schemas.microsoft.com/office/drawing/2014/main" id="{1B581B06-C2D5-4E51-BBCB-498C6652EAA4}"/>
+                <a16:creationId xmlns:a16="http://schemas.microsoft.com/office/drawing/2014/main" id="{7EC91F40-CAE8-4D02-9647-95A70F1C5676}"/>
               </a:ext>
             </a:extLst>
           </p:cNvPr>
@@ -12531,7 +12531,7 @@
           <p:cNvPr id="6" name="">
             <a:extLst xmlns:a="http://schemas.openxmlformats.org/drawingml/2006/main">
               <a:ext uri="{FF2B5EF4-FFF2-40B4-BE49-F238E27FC236}">
-                <a16:creationId xmlns:a16="http://schemas.microsoft.com/office/drawing/2014/main" id="{BD07B866-4212-4444-A30C-B28AEDB02A1D}"/>
+                <a16:creationId xmlns:a16="http://schemas.microsoft.com/office/drawing/2014/main" id="{C595D164-8311-4FFC-9720-A47B4CCD2509}"/>
               </a:ext>
             </a:extLst>
           </p:cNvPr>
@@ -12634,7 +12634,7 @@
           <p:cNvPr id="7" name="">
             <a:extLst xmlns:a="http://schemas.openxmlformats.org/drawingml/2006/main">
               <a:ext uri="{FF2B5EF4-FFF2-40B4-BE49-F238E27FC236}">
-                <a16:creationId xmlns:a16="http://schemas.microsoft.com/office/drawing/2014/main" id="{9AF79A81-7DAF-426E-9625-AB37916B28D7}"/>
+                <a16:creationId xmlns:a16="http://schemas.microsoft.com/office/drawing/2014/main" id="{9AD6F9C9-F5B9-4233-AF5C-8C882741AA65}"/>
               </a:ext>
             </a:extLst>
           </p:cNvPr>
@@ -12691,7 +12691,7 @@
           <p:cNvPr id="8" name="">
             <a:extLst xmlns:a="http://schemas.openxmlformats.org/drawingml/2006/main">
               <a:ext uri="{FF2B5EF4-FFF2-40B4-BE49-F238E27FC236}">
-                <a16:creationId xmlns:a16="http://schemas.microsoft.com/office/drawing/2014/main" id="{54101861-F83B-49B8-80A4-004A0FD422B9}"/>
+                <a16:creationId xmlns:a16="http://schemas.microsoft.com/office/drawing/2014/main" id="{0CDB41DC-9AB6-4EE0-A01B-11E2395F03DD}"/>
               </a:ext>
             </a:extLst>
           </p:cNvPr>
@@ -12794,7 +12794,7 @@
           <p:cNvPr id="9" name="">
             <a:extLst xmlns:a="http://schemas.openxmlformats.org/drawingml/2006/main">
               <a:ext uri="{FF2B5EF4-FFF2-40B4-BE49-F238E27FC236}">
-                <a16:creationId xmlns:a16="http://schemas.microsoft.com/office/drawing/2014/main" id="{DF41D201-5855-45D3-A1FE-7F9C1C7024C1}"/>
+                <a16:creationId xmlns:a16="http://schemas.microsoft.com/office/drawing/2014/main" id="{9B896E4E-C581-44A7-A2E5-8F348722426C}"/>
               </a:ext>
             </a:extLst>
           </p:cNvPr>
@@ -12849,7 +12849,7 @@
     </p:spTree>
     <p:extLst>
       <p:ext uri="{BB962C8B-B14F-4D97-AF65-F5344CB8AC3E}">
-        <p14:creationId xmlns:p14="http://schemas.microsoft.com/office/powerpoint/2010/main" val="2021310911"/>
+        <p14:creationId xmlns:p14="http://schemas.microsoft.com/office/powerpoint/2010/main" val="2012815491"/>
       </p:ext>
     </p:extLst>
   </p:cSld>

</xml_diff>